<commit_message>
- parametre med lambda i stedet for type-cast af "object". - løsningforslag, som compiler med .NET 10
</commit_message>
<xml_diff>
--- a/05 Parallel programming/Threading.pptx
+++ b/05 Parallel programming/Threading.pptx
@@ -141,37 +141,37 @@
 </p:presentation>
 </file>
 
+<file path=ppt/revisionInfo.xml><?xml version="1.0" encoding="utf-8"?>
+<p1510:revInfo xmlns:a="http://schemas.openxmlformats.org/drawingml/2006/main" xmlns:r="http://schemas.openxmlformats.org/officeDocument/2006/relationships" xmlns:p1510="http://schemas.microsoft.com/office/powerpoint/2015/10/main">
+  <p1510:revLst>
+    <p1510:client id="{B5F4D141-3253-4A71-BC80-59CDE20B15A7}" v="3" dt="2026-09-16T12:14:30.627"/>
+  </p1510:revLst>
+</p1510:revInfo>
+</file>
+
 <file path=ppt/changesInfos/changesInfo1.xml><?xml version="1.0" encoding="utf-8"?>
 <pc:chgInfo xmlns:a="http://schemas.openxmlformats.org/drawingml/2006/main" xmlns:r="http://schemas.openxmlformats.org/officeDocument/2006/relationships" xmlns:ac="http://schemas.microsoft.com/office/drawing/2013/main/command" xmlns:pc="http://schemas.microsoft.com/office/powerpoint/2013/main/command">
   <pc:docChgLst>
-    <pc:chgData name="Michael Sørensen Loft" userId="42949a3e-5aba-4e5d-931a-6d7b2cf6ec97" providerId="ADAL" clId="{552BF22B-4B0C-4759-B9D8-0FF28FF5F14A}"/>
-    <pc:docChg chg="custSel modSld">
-      <pc:chgData name="Michael Sørensen Loft" userId="42949a3e-5aba-4e5d-931a-6d7b2cf6ec97" providerId="ADAL" clId="{552BF22B-4B0C-4759-B9D8-0FF28FF5F14A}" dt="2024-09-25T18:35:09.112" v="2" actId="1076"/>
+    <pc:chgData name="Michael Sørensen Loft" userId="42949a3e-5aba-4e5d-931a-6d7b2cf6ec97" providerId="ADAL" clId="{FA52C119-A23A-4EFB-B8A5-4BE503ADFC14}"/>
+    <pc:docChg chg="modSld">
+      <pc:chgData name="Michael Sørensen Loft" userId="42949a3e-5aba-4e5d-931a-6d7b2cf6ec97" providerId="ADAL" clId="{FA52C119-A23A-4EFB-B8A5-4BE503ADFC14}" dt="2026-09-16T12:13:09.767" v="0"/>
       <pc:docMkLst>
         <pc:docMk/>
       </pc:docMkLst>
-      <pc:sldChg chg="addSp delSp modSp mod">
-        <pc:chgData name="Michael Sørensen Loft" userId="42949a3e-5aba-4e5d-931a-6d7b2cf6ec97" providerId="ADAL" clId="{552BF22B-4B0C-4759-B9D8-0FF28FF5F14A}" dt="2024-09-25T18:35:09.112" v="2" actId="1076"/>
+      <pc:sldChg chg="modSp">
+        <pc:chgData name="Michael Sørensen Loft" userId="42949a3e-5aba-4e5d-931a-6d7b2cf6ec97" providerId="ADAL" clId="{FA52C119-A23A-4EFB-B8A5-4BE503ADFC14}" dt="2026-09-16T12:13:09.767" v="0"/>
         <pc:sldMkLst>
           <pc:docMk/>
-          <pc:sldMk cId="1292881404" sldId="279"/>
+          <pc:sldMk cId="3879835632" sldId="272"/>
         </pc:sldMkLst>
-        <pc:picChg chg="add mod">
-          <ac:chgData name="Michael Sørensen Loft" userId="42949a3e-5aba-4e5d-931a-6d7b2cf6ec97" providerId="ADAL" clId="{552BF22B-4B0C-4759-B9D8-0FF28FF5F14A}" dt="2024-09-25T18:35:09.112" v="2" actId="1076"/>
-          <ac:picMkLst>
+        <pc:spChg chg="mod">
+          <ac:chgData name="Michael Sørensen Loft" userId="42949a3e-5aba-4e5d-931a-6d7b2cf6ec97" providerId="ADAL" clId="{FA52C119-A23A-4EFB-B8A5-4BE503ADFC14}" dt="2026-09-16T12:13:09.767" v="0"/>
+          <ac:spMkLst>
             <pc:docMk/>
-            <pc:sldMk cId="1292881404" sldId="279"/>
-            <ac:picMk id="3" creationId="{1CE9F7EC-E54B-E58F-1309-2FBE114103EF}"/>
-          </ac:picMkLst>
-        </pc:picChg>
-        <pc:picChg chg="del">
-          <ac:chgData name="Michael Sørensen Loft" userId="42949a3e-5aba-4e5d-931a-6d7b2cf6ec97" providerId="ADAL" clId="{552BF22B-4B0C-4759-B9D8-0FF28FF5F14A}" dt="2024-09-25T18:35:05.608" v="0" actId="478"/>
-          <ac:picMkLst>
-            <pc:docMk/>
-            <pc:sldMk cId="1292881404" sldId="279"/>
-            <ac:picMk id="9" creationId="{00000000-0000-0000-0000-000000000000}"/>
-          </ac:picMkLst>
-        </pc:picChg>
+            <pc:sldMk cId="3879835632" sldId="272"/>
+            <ac:spMk id="4" creationId="{00000000-0000-0000-0000-000000000000}"/>
+          </ac:spMkLst>
+        </pc:spChg>
       </pc:sldChg>
     </pc:docChg>
   </pc:docChgLst>
@@ -260,7 +260,7 @@
           <a:p>
             <a:fld id="{C3D45B35-5990-4A22-9246-3EAB55A12994}" type="datetimeFigureOut">
               <a:rPr lang="da-DK" smtClean="0"/>
-              <a:t>17-09-2025</a:t>
+              <a:t>15-09-2026</a:t>
             </a:fld>
             <a:endParaRPr lang="da-DK"/>
           </a:p>
@@ -3090,11 +3090,11 @@
           <a:p>
             <a:r>
               <a:rPr lang="da-DK" dirty="0"/>
-              <a:t>Or </a:t>
+              <a:t>An </a:t>
             </a:r>
             <a:r>
               <a:rPr lang="da-DK" dirty="0" err="1"/>
-              <a:t>we</a:t>
+              <a:t>older</a:t>
             </a:r>
             <a:r>
               <a:rPr lang="da-DK" dirty="0"/>
@@ -3102,104 +3102,46 @@
             </a:r>
             <a:r>
               <a:rPr lang="da-DK" dirty="0" err="1"/>
-              <a:t>can</a:t>
+              <a:t>method</a:t>
             </a:r>
             <a:r>
               <a:rPr lang="da-DK" dirty="0"/>
-              <a:t> </a:t>
+              <a:t> is to </a:t>
             </a:r>
             <a:r>
               <a:rPr lang="da-DK" dirty="0" err="1"/>
               <a:t>pass</a:t>
             </a:r>
             <a:r>
-              <a:rPr lang="da-DK" baseline="0" dirty="0"/>
-              <a:t> parameters to the </a:t>
-            </a:r>
-            <a:r>
-              <a:rPr lang="da-DK" baseline="0" dirty="0" err="1"/>
-              <a:t>thread</a:t>
-            </a:r>
-            <a:r>
-              <a:rPr lang="da-DK" baseline="0" dirty="0"/>
-              <a:t>, </a:t>
-            </a:r>
-            <a:r>
-              <a:rPr lang="da-DK" baseline="0" dirty="0" err="1"/>
-              <a:t>when</a:t>
-            </a:r>
-            <a:r>
-              <a:rPr lang="da-DK" baseline="0" dirty="0"/>
-              <a:t> </a:t>
-            </a:r>
-            <a:r>
-              <a:rPr lang="da-DK" baseline="0" dirty="0" err="1"/>
-              <a:t>we</a:t>
-            </a:r>
-            <a:r>
-              <a:rPr lang="da-DK" baseline="0" dirty="0"/>
-              <a:t> start the </a:t>
-            </a:r>
-            <a:r>
-              <a:rPr lang="da-DK" baseline="0" dirty="0" err="1"/>
-              <a:t>thread</a:t>
-            </a:r>
-            <a:r>
-              <a:rPr lang="da-DK" baseline="0" dirty="0"/>
-              <a:t>.</a:t>
-            </a:r>
-            <a:endParaRPr lang="da-DK" dirty="0"/>
-          </a:p>
-          <a:p>
-            <a:endParaRPr lang="da-DK" dirty="0"/>
-          </a:p>
-          <a:p>
-            <a:r>
               <a:rPr lang="da-DK" dirty="0"/>
-              <a:t>NOTE: </a:t>
+              <a:t> the parameter as an </a:t>
             </a:r>
             <a:r>
               <a:rPr lang="da-DK" dirty="0" err="1"/>
-              <a:t>We</a:t>
+              <a:t>object</a:t>
             </a:r>
             <a:r>
               <a:rPr lang="da-DK" dirty="0"/>
-              <a:t> </a:t>
-            </a:r>
-            <a:r>
-              <a:rPr lang="da-DK" dirty="0" err="1"/>
-              <a:t>could</a:t>
-            </a:r>
-            <a:r>
-              <a:rPr lang="da-DK" dirty="0"/>
-              <a:t> </a:t>
-            </a:r>
-            <a:r>
-              <a:rPr lang="da-DK" dirty="0" err="1"/>
-              <a:t>also</a:t>
-            </a:r>
-            <a:r>
-              <a:rPr lang="da-DK" dirty="0"/>
-              <a:t> </a:t>
-            </a:r>
-            <a:r>
-              <a:rPr lang="da-DK" dirty="0" err="1"/>
-              <a:t>use</a:t>
-            </a:r>
-            <a:r>
-              <a:rPr lang="da-DK" dirty="0"/>
-              <a:t> lambda </a:t>
-            </a:r>
-            <a:r>
-              <a:rPr lang="da-DK" dirty="0" err="1"/>
-              <a:t>expressions</a:t>
-            </a:r>
-            <a:r>
-              <a:rPr lang="da-DK" dirty="0"/>
-              <a:t> https://stackoverflow.com/questions/1195896/threadstart-with-parameters</a:t>
-            </a:r>
-          </a:p>
-          <a:p>
+              <a:t>: </a:t>
+            </a:r>
+            <a:r>
+              <a:rPr lang="en-GB" dirty="0">
+                <a:latin typeface="Gill Sans MT" panose="020B0502020104020203" pitchFamily="34" charset="0"/>
+                <a:hlinkClick r:id="rId3"/>
+              </a:rPr>
+              <a:t>https://learn.microsoft.com/en-us/dotnet/api/system.threading.thread.start?view=net-6.0#system-threading-thread-start(system-object)</a:t>
+            </a:r>
+            <a:endParaRPr lang="en-GB" dirty="0">
+              <a:latin typeface="Gill Sans MT" panose="020B0502020104020203" pitchFamily="34" charset="0"/>
+            </a:endParaRPr>
+          </a:p>
+          <a:p>
+            <a:r>
+              <a:rPr lang="en-GB" dirty="0">
+                <a:latin typeface="Gill Sans MT" panose="020B0502020104020203" pitchFamily="34" charset="0"/>
+              </a:rPr>
+              <a:t>But that is not type safe.</a:t>
+            </a:r>
             <a:endParaRPr lang="da-DK" dirty="0"/>
           </a:p>
         </p:txBody>
@@ -7479,13 +7421,16 @@
             </a:r>
             <a:r>
               <a:rPr lang="da-DK" dirty="0"/>
-              <a:t> parameters – To the Start() </a:t>
+              <a:t> parameters – </a:t>
             </a:r>
             <a:r>
               <a:rPr lang="da-DK" dirty="0" err="1"/>
-              <a:t>method</a:t>
-            </a:r>
-            <a:endParaRPr lang="da-DK" dirty="0"/>
+              <a:t>using</a:t>
+            </a:r>
+            <a:r>
+              <a:rPr lang="da-DK" dirty="0"/>
+              <a:t> lambdas</a:t>
+            </a:r>
           </a:p>
         </p:txBody>
       </p:sp>
@@ -7680,7 +7625,18 @@
               <a:rPr lang="da-DK" sz="1400" b="1" dirty="0">
                 <a:latin typeface="Consolas" panose="020B0609020204030204" pitchFamily="49" charset="0"/>
               </a:rPr>
-              <a:t> = new Thread(</a:t>
+              <a:t> = </a:t>
+            </a:r>
+          </a:p>
+          <a:p>
+            <a:pPr marL="0" indent="0">
+              <a:buNone/>
+            </a:pPr>
+            <a:r>
+              <a:rPr lang="da-DK" sz="1400" b="1" dirty="0">
+                <a:latin typeface="Consolas" panose="020B0609020204030204" pitchFamily="49" charset="0"/>
+              </a:rPr>
+              <a:t>          new Thread(() =&gt; </a:t>
             </a:r>
             <a:r>
               <a:rPr lang="da-DK" sz="1400" b="1" dirty="0" err="1">
@@ -7692,7 +7648,7 @@
               <a:rPr lang="da-DK" sz="1400" b="1" dirty="0">
                 <a:latin typeface="Consolas" panose="020B0609020204030204" pitchFamily="49" charset="0"/>
               </a:rPr>
-              <a:t>);</a:t>
+              <a:t>(500));</a:t>
             </a:r>
           </a:p>
           <a:p>
@@ -7723,7 +7679,7 @@
               <a:rPr lang="da-DK" sz="1400" b="1" dirty="0">
                 <a:latin typeface="Consolas" panose="020B0609020204030204" pitchFamily="49" charset="0"/>
               </a:rPr>
-              <a:t>(500);</a:t>
+              <a:t>();</a:t>
             </a:r>
           </a:p>
           <a:p>
@@ -8038,13 +7994,25 @@
               <a:rPr lang="da-DK" sz="1400" b="1" dirty="0" err="1">
                 <a:latin typeface="Consolas" panose="020B0609020204030204" pitchFamily="49" charset="0"/>
               </a:rPr>
-              <a:t>object</a:t>
-            </a:r>
-            <a:r>
-              <a:rPr lang="da-DK" sz="1400" b="1" dirty="0">
-                <a:latin typeface="Consolas" panose="020B0609020204030204" pitchFamily="49" charset="0"/>
-              </a:rPr>
-              <a:t> parameter)</a:t>
+              <a:t>int</a:t>
+            </a:r>
+            <a:r>
+              <a:rPr lang="da-DK" sz="1400" b="1" dirty="0">
+                <a:latin typeface="Consolas" panose="020B0609020204030204" pitchFamily="49" charset="0"/>
+              </a:rPr>
+              <a:t> </a:t>
+            </a:r>
+            <a:r>
+              <a:rPr lang="da-DK" sz="1400" b="1" dirty="0" err="1">
+                <a:latin typeface="Consolas" panose="020B0609020204030204" pitchFamily="49" charset="0"/>
+              </a:rPr>
+              <a:t>numberOfIterations</a:t>
+            </a:r>
+            <a:r>
+              <a:rPr lang="da-DK" sz="1400" b="1" dirty="0">
+                <a:latin typeface="Consolas" panose="020B0609020204030204" pitchFamily="49" charset="0"/>
+              </a:rPr>
+              <a:t>)</a:t>
             </a:r>
           </a:p>
           <a:p>
@@ -8056,53 +8024,6 @@
                 <a:latin typeface="Consolas" panose="020B0609020204030204" pitchFamily="49" charset="0"/>
               </a:rPr>
               <a:t>    {</a:t>
-            </a:r>
-          </a:p>
-          <a:p>
-            <a:pPr marL="0" indent="0">
-              <a:buNone/>
-            </a:pPr>
-            <a:r>
-              <a:rPr lang="da-DK" sz="1400" b="1" dirty="0">
-                <a:latin typeface="Consolas" panose="020B0609020204030204" pitchFamily="49" charset="0"/>
-              </a:rPr>
-              <a:t>        </a:t>
-            </a:r>
-            <a:r>
-              <a:rPr lang="da-DK" sz="1400" b="1" dirty="0" err="1">
-                <a:latin typeface="Consolas" panose="020B0609020204030204" pitchFamily="49" charset="0"/>
-              </a:rPr>
-              <a:t>int</a:t>
-            </a:r>
-            <a:r>
-              <a:rPr lang="da-DK" sz="1400" b="1" dirty="0">
-                <a:latin typeface="Consolas" panose="020B0609020204030204" pitchFamily="49" charset="0"/>
-              </a:rPr>
-              <a:t> </a:t>
-            </a:r>
-            <a:r>
-              <a:rPr lang="da-DK" sz="1400" b="1" dirty="0" err="1">
-                <a:latin typeface="Consolas" panose="020B0609020204030204" pitchFamily="49" charset="0"/>
-              </a:rPr>
-              <a:t>numberOfIterations</a:t>
-            </a:r>
-            <a:r>
-              <a:rPr lang="da-DK" sz="1400" b="1" dirty="0">
-                <a:latin typeface="Consolas" panose="020B0609020204030204" pitchFamily="49" charset="0"/>
-              </a:rPr>
-              <a:t> = (</a:t>
-            </a:r>
-            <a:r>
-              <a:rPr lang="da-DK" sz="1400" b="1" dirty="0" err="1">
-                <a:latin typeface="Consolas" panose="020B0609020204030204" pitchFamily="49" charset="0"/>
-              </a:rPr>
-              <a:t>int</a:t>
-            </a:r>
-            <a:r>
-              <a:rPr lang="da-DK" sz="1400" b="1" dirty="0">
-                <a:latin typeface="Consolas" panose="020B0609020204030204" pitchFamily="49" charset="0"/>
-              </a:rPr>
-              <a:t>) parameter;</a:t>
             </a:r>
           </a:p>
           <a:p>
@@ -8311,17 +8232,10 @@
         </p:spPr>
         <p:txBody>
           <a:bodyPr vert="horz" wrap="square" lIns="91440" tIns="45720" rIns="91440" bIns="45720" rtlCol="0" anchor="ctr">
-            <a:normAutofit fontScale="70000" lnSpcReduction="20000"/>
+            <a:normAutofit fontScale="77500" lnSpcReduction="20000"/>
           </a:bodyPr>
           <a:lstStyle/>
           <a:p>
-            <a:r>
-              <a:rPr lang="en-GB" dirty="0">
-                <a:latin typeface="Gill Sans MT" panose="020B0502020104020203" pitchFamily="34" charset="0"/>
-                <a:hlinkClick r:id="rId3"/>
-              </a:rPr>
-              <a:t>https://learn.microsoft.com/en-us/dotnet/api/system.threading.thread.start?view=net-6.0#system-threading-thread-start(system-object)</a:t>
-            </a:r>
             <a:r>
               <a:rPr lang="en-GB" dirty="0">
                 <a:latin typeface="Gill Sans MT" panose="020B0502020104020203" pitchFamily="34" charset="0"/>
@@ -15613,7 +15527,19 @@
               <a:rPr lang="en-GB" dirty="0">
                 <a:latin typeface="Gill Sans MT" panose="020B0502020104020203" pitchFamily="34" charset="0"/>
               </a:rPr>
-              <a:t> From .NET 5.0 and onwards, this will add a compile time warning. So close threads in gracefully</a:t>
+              <a:t> From .NET 5.0 and onwards, this will add a compile time warning and give a runtime exception on newer .</a:t>
+            </a:r>
+            <a:r>
+              <a:rPr lang="en-GB">
+                <a:latin typeface="Gill Sans MT" panose="020B0502020104020203" pitchFamily="34" charset="0"/>
+              </a:rPr>
+              <a:t>NET versions. </a:t>
+            </a:r>
+            <a:r>
+              <a:rPr lang="en-GB" dirty="0">
+                <a:latin typeface="Gill Sans MT" panose="020B0502020104020203" pitchFamily="34" charset="0"/>
+              </a:rPr>
+              <a:t>So close threads in gracefully</a:t>
             </a:r>
           </a:p>
         </p:txBody>
@@ -17856,10 +17782,10 @@
       </p:pic>
       <p:pic>
         <p:nvPicPr>
-          <p:cNvPr id="4" name="Picture 3">
+          <p:cNvPr id="3" name="Picture 2">
             <a:extLst>
               <a:ext uri="{FF2B5EF4-FFF2-40B4-BE49-F238E27FC236}">
-                <a16:creationId xmlns:a16="http://schemas.microsoft.com/office/drawing/2014/main" id="{010B7652-9B9E-1E1F-F215-B8B34F42D3EA}"/>
+                <a16:creationId xmlns:a16="http://schemas.microsoft.com/office/drawing/2014/main" id="{77446CD6-3441-BF2E-A43D-5C87F4FF9022}"/>
               </a:ext>
             </a:extLst>
           </p:cNvPr>
@@ -17876,38 +17802,8 @@
         </p:blipFill>
         <p:spPr>
           <a:xfrm>
-            <a:off x="1202849" y="1879650"/>
-            <a:ext cx="9786303" cy="1579180"/>
-          </a:xfrm>
-          <a:prstGeom prst="rect">
-            <a:avLst/>
-          </a:prstGeom>
-        </p:spPr>
-      </p:pic>
-      <p:pic>
-        <p:nvPicPr>
-          <p:cNvPr id="6" name="Picture 5">
-            <a:extLst>
-              <a:ext uri="{FF2B5EF4-FFF2-40B4-BE49-F238E27FC236}">
-                <a16:creationId xmlns:a16="http://schemas.microsoft.com/office/drawing/2014/main" id="{45B4D046-A958-A404-3763-CFFE8F6EC23D}"/>
-              </a:ext>
-            </a:extLst>
-          </p:cNvPr>
-          <p:cNvPicPr>
-            <a:picLocks noChangeAspect="1"/>
-          </p:cNvPicPr>
-          <p:nvPr/>
-        </p:nvPicPr>
-        <p:blipFill>
-          <a:blip r:embed="rId5"/>
-          <a:stretch>
-            <a:fillRect/>
-          </a:stretch>
-        </p:blipFill>
-        <p:spPr>
-          <a:xfrm>
-            <a:off x="8310564" y="3376851"/>
-            <a:ext cx="3209994" cy="3322315"/>
+            <a:off x="1570332" y="1703648"/>
+            <a:ext cx="9332690" cy="1299489"/>
           </a:xfrm>
           <a:prstGeom prst="rect">
             <a:avLst/>

</xml_diff>